<commit_message>
fix: actualizar presentación de MovieMate
</commit_message>
<xml_diff>
--- a/MovieMate_TFG_Presentacion.pptx
+++ b/MovieMate_TFG_Presentacion.pptx
@@ -140,6 +140,9 @@
           </p15:clr>
         </p15:guide>
       </p15:sldGuideLst>
+    </p:ext>
+    <p:ext uri="{2D200454-40CA-4A62-9FC3-DE9A4176ACB9}">
+      <p15:notesGuideLst xmlns:p15="http://schemas.microsoft.com/office/powerpoint/2012/main"/>
     </p:ext>
   </p:extLst>
 </p:presentation>
@@ -20739,7 +20742,7 @@
         </p:nvSpPr>
         <p:spPr>
           <a:xfrm>
-            <a:off x="0" y="0"/>
+            <a:off x="8164" y="8164"/>
             <a:ext cx="12188952" cy="6858000"/>
           </a:xfrm>
           <a:prstGeom prst="rect">

</xml_diff>